<commit_message>
WIP: Arena system, tutorials, kamikaze drones, AI coordination, UI widgets, weapon upgrades
Major additions and improvements across multiple systems:
- Arena manager with wave spawning logic
- Tutorial system (subsystem, widgets, trigger volumes, types)
- Kamikaze drone NPC and spawner
- AI combat coordinator
- EMF charge widget and subsystem
- Checkpoint subsystem extensions
- ShooterNPC AI improvements and optimizations
- Sniper turret, boss AI, weapon enhancements
- Navigation module scaffolding

Co-Authored-By: Claude Opus 4.6 (1M context) <noreply@anthropic.com>
</commit_message>
<xml_diff>
--- a/Polarity/Docs/PitchTemplate.pptx
+++ b/Polarity/Docs/PitchTemplate.pptx
@@ -4,6 +4,9 @@
   <p:sldMasterIdLst>
     <p:sldMasterId id="2147483648" r:id="rId1"/>
   </p:sldMasterIdLst>
+  <p:notesMasterIdLst>
+    <p:notesMasterId r:id="rId12"/>
+  </p:notesMasterIdLst>
   <p:sldIdLst>
     <p:sldId id="256" r:id="rId2"/>
     <p:sldId id="257" r:id="rId3"/>
@@ -16,10 +19,7 @@
     <p:sldId id="264" r:id="rId10"/>
     <p:sldId id="265" r:id="rId11"/>
   </p:sldIdLst>
-  <p:notesMasterIdLst>
-    <p:notesMasterId r:id="rId12"/>
-  </p:notesMasterIdLst>
-  <p:sldSz cx="9144000" cy="5143500"/>
+  <p:sldSz cx="9144000" cy="5143500" type="screen16x9"/>
   <p:notesSz cx="5143500" cy="9144000"/>
   <p:defaultTextStyle>
     <a:lvl1pPr marL="0" algn="l" defTabSz="914400" rtl="0" eaLnBrk="1" latinLnBrk="0" hangingPunct="1">
@@ -113,6 +113,11 @@
       </a:defRPr>
     </a:lvl9pPr>
   </p:defaultTextStyle>
+  <p:extLst>
+    <p:ext uri="{EFAFB233-063F-42B5-8137-9DF3F51BA10A}">
+      <p15:sldGuideLst xmlns:p15="http://schemas.microsoft.com/office/powerpoint/2012/main"/>
+    </p:ext>
+  </p:extLst>
 </p:presentation>
 </file>
 
@@ -138,234 +143,10 @@
           <a:chExt cx="0" cy="0"/>
         </a:xfrm>
       </p:grpSpPr>
-      <p:sp>
-        <p:nvSpPr>
-          <p:cNvPr id="2" name="Header Placeholder 1"/>
-          <p:cNvSpPr>
-            <a:spLocks noGrp="1"/>
-          </p:cNvSpPr>
-          <p:nvPr>
-            <p:ph type="hdr" sz="quarter"/>
-          </p:nvPr>
-        </p:nvSpPr>
-        <p:spPr>
-          <a:xfrm>
-            <a:off x="0" y="0"/>
-            <a:ext cx="2971800" cy="458788"/>
-          </a:xfrm>
-          <a:prstGeom prst="rect">
-            <a:avLst/>
-          </a:prstGeom>
-        </p:spPr>
-        <p:txBody>
-          <a:bodyPr vert="horz" lIns="91440" tIns="45720" rIns="91440" bIns="45720" rtlCol="0"/>
-          <a:lstStyle>
-            <a:lvl1pPr algn="l">
-              <a:defRPr sz="1200"/>
-            </a:lvl1pPr>
-          </a:lstStyle>
-          <a:p>
-            <a:endParaRPr lang="en-US"/>
-          </a:p>
-        </p:txBody>
-      </p:sp>
-      <p:sp>
-        <p:nvSpPr>
-          <p:cNvPr id="3" name="Date Placeholder 2"/>
-          <p:cNvSpPr>
-            <a:spLocks noGrp="1"/>
-          </p:cNvSpPr>
-          <p:nvPr>
-            <p:ph type="dt" idx="1"/>
-          </p:nvPr>
-        </p:nvSpPr>
-        <p:spPr>
-          <a:xfrm>
-            <a:off x="3884613" y="0"/>
-            <a:ext cx="2971800" cy="458788"/>
-          </a:xfrm>
-          <a:prstGeom prst="rect">
-            <a:avLst/>
-          </a:prstGeom>
-        </p:spPr>
-        <p:txBody>
-          <a:bodyPr vert="horz" lIns="91440" tIns="45720" rIns="91440" bIns="45720" rtlCol="0"/>
-          <a:lstStyle>
-            <a:lvl1pPr algn="r">
-              <a:defRPr sz="1200"/>
-            </a:lvl1pPr>
-          </a:lstStyle>
-          <a:p>
-            <a:fld id="{5282F153-3F37-0F45-9E97-73ACFA13230C}" type="datetimeFigureOut">
-              <a:rPr lang="en-US"/>
-              <a:t>7/23/19</a:t>
-            </a:fld>
-            <a:endParaRPr lang="en-US"/>
-          </a:p>
-        </p:txBody>
-      </p:sp>
-      <p:sp>
-        <p:nvSpPr>
-          <p:cNvPr id="4" name="Slide Image Placeholder 3"/>
-          <p:cNvSpPr>
-            <a:spLocks noGrp="1" noRot="1" noChangeAspect="1"/>
-          </p:cNvSpPr>
-          <p:nvPr>
-            <p:ph type="sldImg" idx="2"/>
-          </p:nvPr>
-        </p:nvSpPr>
-        <p:spPr>
-          <a:xfrm>
-            <a:off x="685800" y="1143000"/>
-            <a:ext cx="5486400" cy="3086100"/>
-          </a:xfrm>
-          <a:prstGeom prst="rect">
-            <a:avLst/>
-          </a:prstGeom>
-          <a:noFill/>
-          <a:ln w="12700">
-            <a:solidFill>
-              <a:prstClr val="black"/>
-            </a:solidFill>
-          </a:ln>
-        </p:spPr>
-        <p:txBody>
-          <a:bodyPr vert="horz" lIns="91440" tIns="45720" rIns="91440" bIns="45720" rtlCol="0" anchor="ctr"/>
-          <a:lstStyle/>
-          <a:p>
-            <a:endParaRPr lang="en-US"/>
-          </a:p>
-        </p:txBody>
-      </p:sp>
-      <p:sp>
-        <p:nvSpPr>
-          <p:cNvPr id="5" name="Notes Placeholder 4"/>
-          <p:cNvSpPr>
-            <a:spLocks noGrp="1"/>
-          </p:cNvSpPr>
-          <p:nvPr>
-            <p:ph type="body" sz="quarter" idx="3"/>
-          </p:nvPr>
-        </p:nvSpPr>
-        <p:spPr>
-          <a:xfrm>
-            <a:off x="685800" y="4400550"/>
-            <a:ext cx="5486400" cy="3600450"/>
-          </a:xfrm>
-          <a:prstGeom prst="rect">
-            <a:avLst/>
-          </a:prstGeom>
-        </p:spPr>
-        <p:txBody>
-          <a:bodyPr vert="horz" lIns="91440" tIns="45720" rIns="91440" bIns="45720" rtlCol="0"/>
-          <a:lstStyle/>
-          <a:p>
-            <a:pPr lvl="0"/>
-            <a:r>
-              <a:rPr lang="en-US"/>
-              <a:t>Click to edit Master text styles</a:t>
-            </a:r>
-          </a:p>
-          <a:p>
-            <a:pPr lvl="1"/>
-            <a:r>
-              <a:rPr lang="en-US"/>
-              <a:t>Second level</a:t>
-            </a:r>
-          </a:p>
-          <a:p>
-            <a:pPr lvl="2"/>
-            <a:r>
-              <a:rPr lang="en-US"/>
-              <a:t>Third level</a:t>
-            </a:r>
-          </a:p>
-          <a:p>
-            <a:pPr lvl="3"/>
-            <a:r>
-              <a:rPr lang="en-US"/>
-              <a:t>Fourth level</a:t>
-            </a:r>
-          </a:p>
-          <a:p>
-            <a:pPr lvl="4"/>
-            <a:r>
-              <a:rPr lang="en-US"/>
-              <a:t>Fifth level</a:t>
-            </a:r>
-          </a:p>
-        </p:txBody>
-      </p:sp>
-      <p:sp>
-        <p:nvSpPr>
-          <p:cNvPr id="6" name="Footer Placeholder 5"/>
-          <p:cNvSpPr>
-            <a:spLocks noGrp="1"/>
-          </p:cNvSpPr>
-          <p:nvPr>
-            <p:ph type="ftr" sz="quarter" idx="4"/>
-          </p:nvPr>
-        </p:nvSpPr>
-        <p:spPr>
-          <a:xfrm>
-            <a:off x="0" y="8685213"/>
-            <a:ext cx="2971800" cy="458787"/>
-          </a:xfrm>
-          <a:prstGeom prst="rect">
-            <a:avLst/>
-          </a:prstGeom>
-        </p:spPr>
-        <p:txBody>
-          <a:bodyPr vert="horz" lIns="91440" tIns="45720" rIns="91440" bIns="45720" rtlCol="0" anchor="b"/>
-          <a:lstStyle>
-            <a:lvl1pPr algn="l">
-              <a:defRPr sz="1200"/>
-            </a:lvl1pPr>
-          </a:lstStyle>
-          <a:p>
-            <a:endParaRPr lang="en-US"/>
-          </a:p>
-        </p:txBody>
-      </p:sp>
-      <p:sp>
-        <p:nvSpPr>
-          <p:cNvPr id="7" name="Slide Number Placeholder 6"/>
-          <p:cNvSpPr>
-            <a:spLocks noGrp="1"/>
-          </p:cNvSpPr>
-          <p:nvPr>
-            <p:ph type="sldNum" sz="quarter" idx="5"/>
-          </p:nvPr>
-        </p:nvSpPr>
-        <p:spPr>
-          <a:xfrm>
-            <a:off x="3884613" y="8685213"/>
-            <a:ext cx="2971800" cy="458787"/>
-          </a:xfrm>
-          <a:prstGeom prst="rect">
-            <a:avLst/>
-          </a:prstGeom>
-        </p:spPr>
-        <p:txBody>
-          <a:bodyPr vert="horz" lIns="91440" tIns="45720" rIns="91440" bIns="45720" rtlCol="0" anchor="b"/>
-          <a:lstStyle>
-            <a:lvl1pPr algn="r">
-              <a:defRPr sz="1200"/>
-            </a:lvl1pPr>
-          </a:lstStyle>
-          <a:p>
-            <a:fld id="{CE5E9CC1-C706-0F49-92D6-E571CC5EEA8F}" type="slidenum">
-              <a:rPr lang="en-US"/>
-              <a:t>‹#›</a:t>
-            </a:fld>
-            <a:endParaRPr lang="en-US"/>
-          </a:p>
-        </p:txBody>
-      </p:sp>
     </p:spTree>
     <p:extLst>
       <p:ext uri="{BB962C8B-B14F-4D97-AF65-F5344CB8AC3E}">
-        <p14:creationId xmlns:p14="http://schemas.microsoft.com/office/powerpoint/2010/main" val="1024086991"/>
+        <p14:creationId xmlns:p14="http://schemas.microsoft.com/office/powerpoint/2010/main" val="1696255556"/>
       </p:ext>
     </p:extLst>
   </p:cSld>
@@ -509,10 +290,6 @@
           <a:bodyPr/>
           <a:lstStyle/>
           <a:p>
-            <a:r>
-              <a:rPr lang="en-US" dirty="0"/>
-              <a:t/>
-            </a:r>
             <a:endParaRPr lang="en-US" dirty="0"/>
           </a:p>
         </p:txBody>
@@ -597,10 +374,6 @@
           <a:bodyPr/>
           <a:lstStyle/>
           <a:p>
-            <a:r>
-              <a:rPr lang="en-US" dirty="0"/>
-              <a:t/>
-            </a:r>
             <a:endParaRPr lang="en-US" dirty="0"/>
           </a:p>
         </p:txBody>
@@ -685,10 +458,6 @@
           <a:bodyPr/>
           <a:lstStyle/>
           <a:p>
-            <a:r>
-              <a:rPr lang="en-US" dirty="0"/>
-              <a:t/>
-            </a:r>
             <a:endParaRPr lang="en-US" dirty="0"/>
           </a:p>
         </p:txBody>
@@ -773,10 +542,6 @@
           <a:bodyPr/>
           <a:lstStyle/>
           <a:p>
-            <a:r>
-              <a:rPr lang="en-US" dirty="0"/>
-              <a:t/>
-            </a:r>
             <a:endParaRPr lang="en-US" dirty="0"/>
           </a:p>
         </p:txBody>
@@ -861,10 +626,6 @@
           <a:bodyPr/>
           <a:lstStyle/>
           <a:p>
-            <a:r>
-              <a:rPr lang="en-US" dirty="0"/>
-              <a:t/>
-            </a:r>
             <a:endParaRPr lang="en-US" dirty="0"/>
           </a:p>
         </p:txBody>
@@ -949,10 +710,6 @@
           <a:bodyPr/>
           <a:lstStyle/>
           <a:p>
-            <a:r>
-              <a:rPr lang="en-US" dirty="0"/>
-              <a:t/>
-            </a:r>
             <a:endParaRPr lang="en-US" dirty="0"/>
           </a:p>
         </p:txBody>
@@ -1037,10 +794,6 @@
           <a:bodyPr/>
           <a:lstStyle/>
           <a:p>
-            <a:r>
-              <a:rPr lang="en-US" dirty="0"/>
-              <a:t/>
-            </a:r>
             <a:endParaRPr lang="en-US" dirty="0"/>
           </a:p>
         </p:txBody>
@@ -1125,10 +878,6 @@
           <a:bodyPr/>
           <a:lstStyle/>
           <a:p>
-            <a:r>
-              <a:rPr lang="en-US" dirty="0"/>
-              <a:t/>
-            </a:r>
             <a:endParaRPr lang="en-US" dirty="0"/>
           </a:p>
         </p:txBody>
@@ -1213,10 +962,6 @@
           <a:bodyPr/>
           <a:lstStyle/>
           <a:p>
-            <a:r>
-              <a:rPr lang="en-US" dirty="0"/>
-              <a:t/>
-            </a:r>
             <a:endParaRPr lang="en-US" dirty="0"/>
           </a:p>
         </p:txBody>
@@ -1301,10 +1046,6 @@
           <a:bodyPr/>
           <a:lstStyle/>
           <a:p>
-            <a:r>
-              <a:rPr lang="en-US" dirty="0"/>
-              <a:t/>
-            </a:r>
             <a:endParaRPr lang="en-US" dirty="0"/>
           </a:p>
         </p:txBody>
@@ -1378,6 +1119,11 @@
 <file path=ppt/slideMasters/slideMaster1.xml><?xml version="1.0" encoding="utf-8"?>
 <p:sldMaster xmlns:a="http://schemas.openxmlformats.org/drawingml/2006/main" xmlns:r="http://schemas.openxmlformats.org/officeDocument/2006/relationships" xmlns:p="http://schemas.openxmlformats.org/presentationml/2006/main">
   <p:cSld>
+    <p:bg>
+      <p:bgRef idx="1001">
+        <a:schemeClr val="bg1"/>
+      </p:bgRef>
+    </p:bg>
     <p:spTree>
       <p:nvGrpSpPr>
         <p:cNvPr id="1" name=""/>
@@ -1660,6 +1406,7 @@
         <a:solidFill>
           <a:srgbClr val="0B0E17"/>
         </a:solidFill>
+        <a:effectLst/>
       </p:bgPr>
     </p:bg>
     <p:spTree>
@@ -1829,11 +1576,11 @@
           <a:bodyPr wrap="square" lIns="0" tIns="0" rIns="0" bIns="0" rtlCol="0" anchor="ctr"/>
           <a:lstStyle/>
           <a:p>
-            <a:pPr algn="ctr" indent="0" marL="0">
+            <a:pPr marL="0" indent="0" algn="ctr">
               <a:buNone/>
             </a:pPr>
             <a:r>
-              <a:rPr lang="en-US" sz="4200" spc="800" kern="0" dirty="0">
+              <a:rPr lang="en-US" sz="4200" kern="0" spc="800" dirty="0">
                 <a:solidFill>
                   <a:srgbClr val="F0F0F0"/>
                 </a:solidFill>
@@ -1891,11 +1638,11 @@
           <a:bodyPr wrap="square" lIns="0" tIns="0" rIns="0" bIns="0" rtlCol="0" anchor="ctr"/>
           <a:lstStyle/>
           <a:p>
-            <a:pPr algn="ctr" indent="0" marL="0">
+            <a:pPr marL="0" indent="0" algn="ctr">
               <a:buNone/>
             </a:pPr>
             <a:r>
-              <a:rPr lang="en-US" sz="1200" spc="600" kern="0" dirty="0">
+              <a:rPr lang="en-US" sz="1200" kern="0" spc="600" dirty="0">
                 <a:solidFill>
                   <a:srgbClr val="6B7280"/>
                 </a:solidFill>
@@ -1930,7 +1677,7 @@
           <a:bodyPr wrap="square" lIns="0" tIns="0" rIns="0" bIns="0" rtlCol="0" anchor="ctr"/>
           <a:lstStyle/>
           <a:p>
-            <a:pPr algn="ctr" indent="0" marL="0">
+            <a:pPr marL="0" indent="0" algn="ctr">
               <a:buNone/>
             </a:pPr>
             <a:r>
@@ -1969,7 +1716,7 @@
           <a:bodyPr wrap="square" lIns="0" tIns="0" rIns="0" bIns="0" rtlCol="0" anchor="ctr"/>
           <a:lstStyle/>
           <a:p>
-            <a:pPr algn="ctr" indent="0" marL="0">
+            <a:pPr marL="0" indent="0" algn="ctr">
               <a:buNone/>
             </a:pPr>
             <a:r>
@@ -2003,6 +1750,7 @@
         <a:solidFill>
           <a:srgbClr val="0B0E17"/>
         </a:solidFill>
+        <a:effectLst/>
       </p:bgPr>
     </p:bg>
     <p:spTree>
@@ -2172,11 +1920,11 @@
           <a:bodyPr wrap="square" lIns="0" tIns="0" rIns="0" bIns="0" rtlCol="0" anchor="ctr"/>
           <a:lstStyle/>
           <a:p>
-            <a:pPr algn="ctr" indent="0" marL="0">
+            <a:pPr marL="0" indent="0" algn="ctr">
               <a:buNone/>
             </a:pPr>
             <a:r>
-              <a:rPr lang="en-US" sz="3600" spc="600" kern="0" dirty="0">
+              <a:rPr lang="en-US" sz="3600" kern="0" spc="600" dirty="0">
                 <a:solidFill>
                   <a:srgbClr val="F0F0F0"/>
                 </a:solidFill>
@@ -2234,7 +1982,7 @@
           <a:bodyPr wrap="square" lIns="0" tIns="0" rIns="0" bIns="0" rtlCol="0" anchor="ctr"/>
           <a:lstStyle/>
           <a:p>
-            <a:pPr algn="ctr" indent="0" marL="0">
+            <a:pPr marL="0" indent="0" algn="ctr">
               <a:buNone/>
             </a:pPr>
             <a:r>
@@ -2273,7 +2021,7 @@
           <a:bodyPr wrap="square" lIns="0" tIns="0" rIns="0" bIns="0" rtlCol="0" anchor="ctr"/>
           <a:lstStyle/>
           <a:p>
-            <a:pPr algn="ctr" indent="0" marL="0">
+            <a:pPr marL="0" indent="0" algn="ctr">
               <a:lnSpc>
                 <a:spcPct val="160000"/>
               </a:lnSpc>
@@ -2293,7 +2041,7 @@
             <a:endParaRPr lang="en-US" sz="1100" dirty="0"/>
           </a:p>
           <a:p>
-            <a:pPr algn="ctr" indent="0" marL="0">
+            <a:pPr marL="0" indent="0" algn="ctr">
               <a:lnSpc>
                 <a:spcPct val="160000"/>
               </a:lnSpc>
@@ -2313,7 +2061,7 @@
             <a:endParaRPr lang="en-US" sz="1100" dirty="0"/>
           </a:p>
           <a:p>
-            <a:pPr algn="ctr" indent="0" marL="0">
+            <a:pPr marL="0" indent="0" algn="ctr">
               <a:lnSpc>
                 <a:spcPct val="160000"/>
               </a:lnSpc>
@@ -2350,6 +2098,7 @@
         <a:solidFill>
           <a:srgbClr val="0B0E17"/>
         </a:solidFill>
+        <a:effectLst/>
       </p:bgPr>
     </p:bg>
     <p:spTree>
@@ -2519,7 +2268,7 @@
           <a:bodyPr wrap="square" lIns="0" tIns="0" rIns="0" bIns="0" rtlCol="0" anchor="ctr"/>
           <a:lstStyle/>
           <a:p>
-            <a:pPr indent="0" marL="0">
+            <a:pPr marL="0" indent="0">
               <a:buNone/>
             </a:pPr>
             <a:r>
@@ -2558,11 +2307,11 @@
           <a:bodyPr wrap="square" lIns="0" tIns="0" rIns="0" bIns="0" rtlCol="0" anchor="ctr"/>
           <a:lstStyle/>
           <a:p>
-            <a:pPr indent="0" marL="0">
+            <a:pPr marL="0" indent="0">
               <a:buNone/>
             </a:pPr>
             <a:r>
-              <a:rPr lang="en-US" sz="2200" spc="200" kern="0" dirty="0">
+              <a:rPr lang="en-US" sz="2200" kern="0" spc="200" dirty="0">
                 <a:solidFill>
                   <a:srgbClr val="F0F0F0"/>
                 </a:solidFill>
@@ -2620,7 +2369,7 @@
           <a:bodyPr wrap="square" lIns="0" tIns="0" rIns="0" bIns="0" rtlCol="0" anchor="ctr"/>
           <a:lstStyle/>
           <a:p>
-            <a:pPr indent="0" marL="0">
+            <a:pPr marL="0" indent="0">
               <a:buNone/>
             </a:pPr>
             <a:r>
@@ -2659,7 +2408,7 @@
           <a:bodyPr wrap="square" lIns="0" tIns="0" rIns="0" bIns="0" rtlCol="0" anchor="t"/>
           <a:lstStyle/>
           <a:p>
-            <a:pPr algn="l" indent="0" marL="0">
+            <a:pPr marL="0" indent="0" algn="l">
               <a:lnSpc>
                 <a:spcPct val="130000"/>
               </a:lnSpc>
@@ -2701,7 +2450,7 @@
           <a:bodyPr wrap="square" lIns="0" tIns="0" rIns="0" bIns="0" rtlCol="0" anchor="ctr"/>
           <a:lstStyle/>
           <a:p>
-            <a:pPr indent="0" marL="0">
+            <a:pPr marL="0" indent="0">
               <a:buNone/>
             </a:pPr>
             <a:r>
@@ -2867,7 +2616,7 @@
           <a:bodyPr wrap="square" lIns="0" tIns="0" rIns="0" bIns="0" rtlCol="0" anchor="ctr"/>
           <a:lstStyle/>
           <a:p>
-            <a:pPr indent="0" marL="0">
+            <a:pPr marL="0" indent="0">
               <a:buNone/>
             </a:pPr>
             <a:r>
@@ -2901,6 +2650,7 @@
         <a:solidFill>
           <a:srgbClr val="0B0E17"/>
         </a:solidFill>
+        <a:effectLst/>
       </p:bgPr>
     </p:bg>
     <p:spTree>
@@ -3070,7 +2820,7 @@
           <a:bodyPr wrap="square" lIns="0" tIns="0" rIns="0" bIns="0" rtlCol="0" anchor="ctr"/>
           <a:lstStyle/>
           <a:p>
-            <a:pPr indent="0" marL="0">
+            <a:pPr marL="0" indent="0">
               <a:buNone/>
             </a:pPr>
             <a:r>
@@ -3109,11 +2859,11 @@
           <a:bodyPr wrap="square" lIns="0" tIns="0" rIns="0" bIns="0" rtlCol="0" anchor="ctr"/>
           <a:lstStyle/>
           <a:p>
-            <a:pPr indent="0" marL="0">
+            <a:pPr marL="0" indent="0">
               <a:buNone/>
             </a:pPr>
             <a:r>
-              <a:rPr lang="en-US" sz="2200" spc="200" kern="0" dirty="0">
+              <a:rPr lang="en-US" sz="2200" kern="0" spc="200" dirty="0">
                 <a:solidFill>
                   <a:srgbClr val="F0F0F0"/>
                 </a:solidFill>
@@ -3229,7 +2979,51 @@
                 <a:ea typeface="Arial" pitchFamily="34" charset="-122"/>
                 <a:cs typeface="Arial" pitchFamily="34" charset="-120"/>
               </a:rPr>
-              <a:t>все объекты и враги на уровне имеют заряд — одноимённые отталкиваются, разноимённые притягиваются</a:t>
+              <a:t>все объекты и враги на уровне имеют заряд — </a:t>
+            </a:r>
+            <a:r>
+              <a:rPr lang="en-US" sz="1000" dirty="0" err="1">
+                <a:solidFill>
+                  <a:srgbClr val="F0F0F0"/>
+                </a:solidFill>
+                <a:latin typeface="Arial" pitchFamily="34" charset="0"/>
+                <a:ea typeface="Arial" pitchFamily="34" charset="-122"/>
+                <a:cs typeface="Arial" pitchFamily="34" charset="-120"/>
+              </a:rPr>
+              <a:t>одноимённые</a:t>
+            </a:r>
+            <a:r>
+              <a:rPr lang="en-US" sz="1000" dirty="0">
+                <a:solidFill>
+                  <a:srgbClr val="F0F0F0"/>
+                </a:solidFill>
+                <a:latin typeface="Arial" pitchFamily="34" charset="0"/>
+                <a:ea typeface="Arial" pitchFamily="34" charset="-122"/>
+                <a:cs typeface="Arial" pitchFamily="34" charset="-120"/>
+              </a:rPr>
+              <a:t> </a:t>
+            </a:r>
+            <a:r>
+              <a:rPr lang="en-US" sz="1000" dirty="0" err="1">
+                <a:solidFill>
+                  <a:srgbClr val="F0F0F0"/>
+                </a:solidFill>
+                <a:latin typeface="Arial" pitchFamily="34" charset="0"/>
+                <a:ea typeface="Arial" pitchFamily="34" charset="-122"/>
+                <a:cs typeface="Arial" pitchFamily="34" charset="-120"/>
+              </a:rPr>
+              <a:t>отталкиваются</a:t>
+            </a:r>
+            <a:r>
+              <a:rPr lang="en-US" sz="1000" dirty="0">
+                <a:solidFill>
+                  <a:srgbClr val="F0F0F0"/>
+                </a:solidFill>
+                <a:latin typeface="Arial" pitchFamily="34" charset="0"/>
+                <a:ea typeface="Arial" pitchFamily="34" charset="-122"/>
+                <a:cs typeface="Arial" pitchFamily="34" charset="-120"/>
+              </a:rPr>
+              <a:t>, разноимённые притягиваются</a:t>
             </a:r>
             <a:endParaRPr lang="en-US" sz="1000" dirty="0"/>
           </a:p>
@@ -3439,9 +3233,8 @@
                 <a:ea typeface="Arial" pitchFamily="34" charset="-122"/>
                 <a:cs typeface="Arial" pitchFamily="34" charset="-120"/>
               </a:rPr>
-              <a:t>апгрейды расширяют боевой словарь: 360 Shot, Charge Flip, Testosterone Boost, Suppression Fire</a:t>
-            </a:r>
-            <a:endParaRPr lang="en-US" sz="1000" dirty="0"/>
+              <a:t>апгрейды расширяют боевой словарь: 360 Shot, Charge Flip, Testosterone Boost, Plot Armor</a:t>
+            </a:r>
           </a:p>
           <a:p>
             <a:pPr marL="342900" indent="-342900">
@@ -3451,17 +3244,6 @@
               <a:buSzPct val="100000"/>
               <a:buChar char="•"/>
             </a:pPr>
-            <a:r>
-              <a:rPr lang="en-US" sz="1000" dirty="0">
-                <a:solidFill>
-                  <a:srgbClr val="F0F0F0"/>
-                </a:solidFill>
-                <a:latin typeface="Arial" pitchFamily="34" charset="0"/>
-                <a:ea typeface="Arial" pitchFamily="34" charset="-122"/>
-                <a:cs typeface="Arial" pitchFamily="34" charset="-120"/>
-              </a:rPr>
-              <a:t>Hard-core post-breakbeat music</a:t>
-            </a:r>
             <a:endParaRPr lang="en-US" sz="1000" dirty="0"/>
           </a:p>
         </p:txBody>
@@ -3482,6 +3264,7 @@
         <a:solidFill>
           <a:srgbClr val="0B0E17"/>
         </a:solidFill>
+        <a:effectLst/>
       </p:bgPr>
     </p:bg>
     <p:spTree>
@@ -3651,7 +3434,7 @@
           <a:bodyPr wrap="square" lIns="0" tIns="0" rIns="0" bIns="0" rtlCol="0" anchor="ctr"/>
           <a:lstStyle/>
           <a:p>
-            <a:pPr indent="0" marL="0">
+            <a:pPr marL="0" indent="0">
               <a:buNone/>
             </a:pPr>
             <a:r>
@@ -3690,11 +3473,11 @@
           <a:bodyPr wrap="square" lIns="0" tIns="0" rIns="0" bIns="0" rtlCol="0" anchor="ctr"/>
           <a:lstStyle/>
           <a:p>
-            <a:pPr indent="0" marL="0">
+            <a:pPr marL="0" indent="0">
               <a:buNone/>
             </a:pPr>
             <a:r>
-              <a:rPr lang="en-US" sz="2200" spc="200" kern="0" dirty="0">
+              <a:rPr lang="en-US" sz="2200" kern="0" spc="200" dirty="0">
                 <a:solidFill>
                   <a:srgbClr val="F0F0F0"/>
                 </a:solidFill>
@@ -3752,7 +3535,7 @@
           <a:bodyPr wrap="square" lIns="0" tIns="0" rIns="0" bIns="0" rtlCol="0" anchor="t"/>
           <a:lstStyle/>
           <a:p>
-            <a:pPr indent="0" marL="0">
+            <a:pPr marL="0" indent="0">
               <a:buNone/>
             </a:pPr>
             <a:r>
@@ -3791,7 +3574,7 @@
           <a:bodyPr wrap="square" lIns="0" tIns="0" rIns="0" bIns="0" rtlCol="0" anchor="t"/>
           <a:lstStyle/>
           <a:p>
-            <a:pPr indent="0" marL="0">
+            <a:pPr marL="0" indent="0">
               <a:lnSpc>
                 <a:spcPct val="120000"/>
               </a:lnSpc>
@@ -3833,7 +3616,7 @@
           <a:bodyPr wrap="square" lIns="0" tIns="0" rIns="0" bIns="0" rtlCol="0" anchor="t"/>
           <a:lstStyle/>
           <a:p>
-            <a:pPr indent="0" marL="0">
+            <a:pPr marL="0" indent="0">
               <a:buNone/>
             </a:pPr>
             <a:r>
@@ -3872,7 +3655,7 @@
           <a:bodyPr wrap="square" lIns="0" tIns="0" rIns="0" bIns="0" rtlCol="0" anchor="t"/>
           <a:lstStyle/>
           <a:p>
-            <a:pPr indent="0" marL="0">
+            <a:pPr marL="0" indent="0">
               <a:lnSpc>
                 <a:spcPct val="120000"/>
               </a:lnSpc>
@@ -3914,7 +3697,7 @@
           <a:bodyPr wrap="square" lIns="0" tIns="0" rIns="0" bIns="0" rtlCol="0" anchor="t"/>
           <a:lstStyle/>
           <a:p>
-            <a:pPr indent="0" marL="0">
+            <a:pPr marL="0" indent="0">
               <a:buNone/>
             </a:pPr>
             <a:r>
@@ -3953,7 +3736,7 @@
           <a:bodyPr wrap="square" lIns="0" tIns="0" rIns="0" bIns="0" rtlCol="0" anchor="t"/>
           <a:lstStyle/>
           <a:p>
-            <a:pPr indent="0" marL="0">
+            <a:pPr marL="0" indent="0">
               <a:lnSpc>
                 <a:spcPct val="120000"/>
               </a:lnSpc>
@@ -3995,7 +3778,7 @@
           <a:bodyPr wrap="square" lIns="0" tIns="0" rIns="0" bIns="0" rtlCol="0" anchor="t"/>
           <a:lstStyle/>
           <a:p>
-            <a:pPr indent="0" marL="0">
+            <a:pPr marL="0" indent="0">
               <a:buNone/>
             </a:pPr>
             <a:r>
@@ -4034,7 +3817,7 @@
           <a:bodyPr wrap="square" lIns="0" tIns="0" rIns="0" bIns="0" rtlCol="0" anchor="t"/>
           <a:lstStyle/>
           <a:p>
-            <a:pPr indent="0" marL="0">
+            <a:pPr marL="0" indent="0">
               <a:lnSpc>
                 <a:spcPct val="120000"/>
               </a:lnSpc>
@@ -4076,7 +3859,7 @@
           <a:bodyPr wrap="square" lIns="0" tIns="0" rIns="0" bIns="0" rtlCol="0" anchor="t"/>
           <a:lstStyle/>
           <a:p>
-            <a:pPr indent="0" marL="0">
+            <a:pPr marL="0" indent="0">
               <a:buNone/>
             </a:pPr>
             <a:r>
@@ -4115,7 +3898,7 @@
           <a:bodyPr wrap="square" lIns="0" tIns="0" rIns="0" bIns="0" rtlCol="0" anchor="t"/>
           <a:lstStyle/>
           <a:p>
-            <a:pPr indent="0" marL="0">
+            <a:pPr marL="0" indent="0">
               <a:lnSpc>
                 <a:spcPct val="120000"/>
               </a:lnSpc>
@@ -4152,6 +3935,7 @@
         <a:solidFill>
           <a:srgbClr val="0B0E17"/>
         </a:solidFill>
+        <a:effectLst/>
       </p:bgPr>
     </p:bg>
     <p:spTree>
@@ -4321,7 +4105,7 @@
           <a:bodyPr wrap="square" lIns="0" tIns="0" rIns="0" bIns="0" rtlCol="0" anchor="ctr"/>
           <a:lstStyle/>
           <a:p>
-            <a:pPr indent="0" marL="0">
+            <a:pPr marL="0" indent="0">
               <a:buNone/>
             </a:pPr>
             <a:r>
@@ -4360,11 +4144,11 @@
           <a:bodyPr wrap="square" lIns="0" tIns="0" rIns="0" bIns="0" rtlCol="0" anchor="ctr"/>
           <a:lstStyle/>
           <a:p>
-            <a:pPr indent="0" marL="0">
+            <a:pPr marL="0" indent="0">
               <a:buNone/>
             </a:pPr>
             <a:r>
-              <a:rPr lang="en-US" sz="2200" spc="200" kern="0" dirty="0">
+              <a:rPr lang="en-US" sz="2200" kern="0" spc="200" dirty="0">
                 <a:solidFill>
                   <a:srgbClr val="F0F0F0"/>
                 </a:solidFill>
@@ -4422,7 +4206,7 @@
           <a:bodyPr wrap="square" lIns="0" tIns="0" rIns="0" bIns="0" rtlCol="0" anchor="ctr"/>
           <a:lstStyle/>
           <a:p>
-            <a:pPr indent="0" marL="0">
+            <a:pPr marL="0" indent="0">
               <a:buNone/>
             </a:pPr>
             <a:r>
@@ -4567,7 +4351,7 @@
           <a:bodyPr wrap="square" lIns="0" tIns="0" rIns="0" bIns="0" rtlCol="0" anchor="ctr"/>
           <a:lstStyle/>
           <a:p>
-            <a:pPr indent="0" marL="0">
+            <a:pPr marL="0" indent="0">
               <a:buNone/>
             </a:pPr>
             <a:r>
@@ -4691,7 +4475,7 @@
           <a:bodyPr wrap="square" lIns="0" tIns="0" rIns="0" bIns="0" rtlCol="0" anchor="ctr"/>
           <a:lstStyle/>
           <a:p>
-            <a:pPr indent="0" marL="0">
+            <a:pPr marL="0" indent="0">
               <a:buNone/>
             </a:pPr>
             <a:r>
@@ -4725,6 +4509,7 @@
         <a:solidFill>
           <a:srgbClr val="0B0E17"/>
         </a:solidFill>
+        <a:effectLst/>
       </p:bgPr>
     </p:bg>
     <p:spTree>
@@ -4894,7 +4679,7 @@
           <a:bodyPr wrap="square" lIns="0" tIns="0" rIns="0" bIns="0" rtlCol="0" anchor="ctr"/>
           <a:lstStyle/>
           <a:p>
-            <a:pPr indent="0" marL="0">
+            <a:pPr marL="0" indent="0">
               <a:buNone/>
             </a:pPr>
             <a:r>
@@ -4933,11 +4718,11 @@
           <a:bodyPr wrap="square" lIns="0" tIns="0" rIns="0" bIns="0" rtlCol="0" anchor="ctr"/>
           <a:lstStyle/>
           <a:p>
-            <a:pPr indent="0" marL="0">
+            <a:pPr marL="0" indent="0">
               <a:buNone/>
             </a:pPr>
             <a:r>
-              <a:rPr lang="en-US" sz="2200" spc="200" kern="0" dirty="0">
+              <a:rPr lang="en-US" sz="2200" kern="0" spc="200" dirty="0">
                 <a:solidFill>
                   <a:srgbClr val="F0F0F0"/>
                 </a:solidFill>
@@ -4976,7 +4761,7 @@
       </p:sp>
       <p:graphicFrame>
         <p:nvGraphicFramePr>
-          <p:cNvPr id="7" name="Table 0"/>
+          <p:cNvPr id="11" name="Table 0"/>
           <p:cNvGraphicFramePr>
             <a:graphicFrameLocks noGrp="1"/>
           </p:cNvGraphicFramePr>
@@ -4997,9 +4782,27 @@
             <a:tbl>
               <a:tblPr/>
               <a:tblGrid>
-                <a:gridCol w="1645920"/>
-                <a:gridCol w="2743200"/>
-                <a:gridCol w="3840480"/>
+                <a:gridCol w="1645920">
+                  <a:extLst>
+                    <a:ext uri="{9D8B030D-6E8A-4147-A177-3AD203B41FA5}">
+                      <a16:colId xmlns:a16="http://schemas.microsoft.com/office/drawing/2014/main" val="20000"/>
+                    </a:ext>
+                  </a:extLst>
+                </a:gridCol>
+                <a:gridCol w="2743200">
+                  <a:extLst>
+                    <a:ext uri="{9D8B030D-6E8A-4147-A177-3AD203B41FA5}">
+                      <a16:colId xmlns:a16="http://schemas.microsoft.com/office/drawing/2014/main" val="20001"/>
+                    </a:ext>
+                  </a:extLst>
+                </a:gridCol>
+                <a:gridCol w="3840480">
+                  <a:extLst>
+                    <a:ext uri="{9D8B030D-6E8A-4147-A177-3AD203B41FA5}">
+                      <a16:colId xmlns:a16="http://schemas.microsoft.com/office/drawing/2014/main" val="20002"/>
+                    </a:ext>
+                  </a:extLst>
+                </a:gridCol>
               </a:tblGrid>
               <a:tr h="320040">
                 <a:tc>
@@ -5007,7 +4810,7 @@
                     <a:bodyPr/>
                     <a:lstStyle/>
                     <a:p>
-                      <a:pPr indent="0" marL="0">
+                      <a:pPr marL="0" indent="0">
                         <a:buNone/>
                       </a:pPr>
                       <a:r>
@@ -5021,7 +4824,7 @@
                       <a:endParaRPr lang="en-US" sz="1000" dirty="0"/>
                     </a:p>
                   </a:txBody>
-                  <a:tcPr marL="91440" marR="91440" marT="45720" marB="45720">
+                  <a:tcPr>
                     <a:lnL w="6350" cap="flat" cmpd="sng" algn="ctr">
                       <a:solidFill>
                         <a:srgbClr val="0A3D5C"/>
@@ -5068,7 +4871,7 @@
                     <a:bodyPr/>
                     <a:lstStyle/>
                     <a:p>
-                      <a:pPr indent="0" marL="0">
+                      <a:pPr marL="0" indent="0">
                         <a:buNone/>
                       </a:pPr>
                       <a:r>
@@ -5082,7 +4885,7 @@
                       <a:endParaRPr lang="en-US" sz="1000" dirty="0"/>
                     </a:p>
                   </a:txBody>
-                  <a:tcPr marL="91440" marR="91440" marT="45720" marB="45720">
+                  <a:tcPr>
                     <a:lnL w="6350" cap="flat" cmpd="sng" algn="ctr">
                       <a:solidFill>
                         <a:srgbClr val="0A3D5C"/>
@@ -5129,7 +4932,7 @@
                     <a:bodyPr/>
                     <a:lstStyle/>
                     <a:p>
-                      <a:pPr indent="0" marL="0">
+                      <a:pPr marL="0" indent="0">
                         <a:buNone/>
                       </a:pPr>
                       <a:r>
@@ -5143,7 +4946,7 @@
                       <a:endParaRPr lang="en-US" sz="1000" dirty="0"/>
                     </a:p>
                   </a:txBody>
-                  <a:tcPr marL="91440" marR="91440" marT="45720" marB="45720">
+                  <a:tcPr>
                     <a:lnL w="6350" cap="flat" cmpd="sng" algn="ctr">
                       <a:solidFill>
                         <a:srgbClr val="0A3D5C"/>
@@ -5185,6 +4988,11 @@
                     </a:solidFill>
                   </a:tcPr>
                 </a:tc>
+                <a:extLst>
+                  <a:ext uri="{0D108BD9-81ED-4DB2-BD59-A6C34878D82A}">
+                    <a16:rowId xmlns:a16="http://schemas.microsoft.com/office/drawing/2014/main" val="10000"/>
+                  </a:ext>
+                </a:extLst>
               </a:tr>
               <a:tr h="320040">
                 <a:tc>
@@ -5192,7 +5000,7 @@
                     <a:bodyPr/>
                     <a:lstStyle/>
                     <a:p>
-                      <a:pPr indent="0" marL="0">
+                      <a:pPr marL="0" indent="0">
                         <a:buNone/>
                       </a:pPr>
                       <a:r>
@@ -5206,7 +5014,7 @@
                       <a:endParaRPr lang="en-US" sz="900" dirty="0"/>
                     </a:p>
                   </a:txBody>
-                  <a:tcPr marL="91440" marR="91440" marT="45720" marB="45720">
+                  <a:tcPr>
                     <a:lnL w="6350" cap="flat" cmpd="sng" algn="ctr">
                       <a:solidFill>
                         <a:srgbClr val="0A3D5C"/>
@@ -5253,7 +5061,7 @@
                     <a:bodyPr/>
                     <a:lstStyle/>
                     <a:p>
-                      <a:pPr indent="0" marL="0">
+                      <a:pPr marL="0" indent="0">
                         <a:buNone/>
                       </a:pPr>
                       <a:r>
@@ -5267,7 +5075,7 @@
                       <a:endParaRPr lang="en-US" sz="900" dirty="0"/>
                     </a:p>
                   </a:txBody>
-                  <a:tcPr marL="91440" marR="91440" marT="45720" marB="45720">
+                  <a:tcPr>
                     <a:lnL w="6350" cap="flat" cmpd="sng" algn="ctr">
                       <a:solidFill>
                         <a:srgbClr val="0A3D5C"/>
@@ -5314,7 +5122,7 @@
                     <a:bodyPr/>
                     <a:lstStyle/>
                     <a:p>
-                      <a:pPr indent="0" marL="0">
+                      <a:pPr marL="0" indent="0">
                         <a:buNone/>
                       </a:pPr>
                       <a:r>
@@ -5328,7 +5136,7 @@
                       <a:endParaRPr lang="en-US" sz="900" dirty="0"/>
                     </a:p>
                   </a:txBody>
-                  <a:tcPr marL="91440" marR="91440" marT="45720" marB="45720">
+                  <a:tcPr>
                     <a:lnL w="6350" cap="flat" cmpd="sng" algn="ctr">
                       <a:solidFill>
                         <a:srgbClr val="0A3D5C"/>
@@ -5370,6 +5178,11 @@
                     </a:solidFill>
                   </a:tcPr>
                 </a:tc>
+                <a:extLst>
+                  <a:ext uri="{0D108BD9-81ED-4DB2-BD59-A6C34878D82A}">
+                    <a16:rowId xmlns:a16="http://schemas.microsoft.com/office/drawing/2014/main" val="10001"/>
+                  </a:ext>
+                </a:extLst>
               </a:tr>
               <a:tr h="320040">
                 <a:tc>
@@ -5377,7 +5190,7 @@
                     <a:bodyPr/>
                     <a:lstStyle/>
                     <a:p>
-                      <a:pPr indent="0" marL="0">
+                      <a:pPr marL="0" indent="0">
                         <a:buNone/>
                       </a:pPr>
                       <a:r>
@@ -5391,7 +5204,7 @@
                       <a:endParaRPr lang="en-US" sz="900" dirty="0"/>
                     </a:p>
                   </a:txBody>
-                  <a:tcPr marL="91440" marR="91440" marT="45720" marB="45720">
+                  <a:tcPr>
                     <a:lnL w="6350" cap="flat" cmpd="sng" algn="ctr">
                       <a:solidFill>
                         <a:srgbClr val="0A3D5C"/>
@@ -5438,7 +5251,7 @@
                     <a:bodyPr/>
                     <a:lstStyle/>
                     <a:p>
-                      <a:pPr indent="0" marL="0">
+                      <a:pPr marL="0" indent="0">
                         <a:buNone/>
                       </a:pPr>
                       <a:r>
@@ -5452,7 +5265,7 @@
                       <a:endParaRPr lang="en-US" sz="900" dirty="0"/>
                     </a:p>
                   </a:txBody>
-                  <a:tcPr marL="91440" marR="91440" marT="45720" marB="45720">
+                  <a:tcPr>
                     <a:lnL w="6350" cap="flat" cmpd="sng" algn="ctr">
                       <a:solidFill>
                         <a:srgbClr val="0A3D5C"/>
@@ -5499,7 +5312,7 @@
                     <a:bodyPr/>
                     <a:lstStyle/>
                     <a:p>
-                      <a:pPr indent="0" marL="0">
+                      <a:pPr marL="0" indent="0">
                         <a:buNone/>
                       </a:pPr>
                       <a:r>
@@ -5513,7 +5326,7 @@
                       <a:endParaRPr lang="en-US" sz="900" dirty="0"/>
                     </a:p>
                   </a:txBody>
-                  <a:tcPr marL="91440" marR="91440" marT="45720" marB="45720">
+                  <a:tcPr>
                     <a:lnL w="6350" cap="flat" cmpd="sng" algn="ctr">
                       <a:solidFill>
                         <a:srgbClr val="0A3D5C"/>
@@ -5555,6 +5368,11 @@
                     </a:solidFill>
                   </a:tcPr>
                 </a:tc>
+                <a:extLst>
+                  <a:ext uri="{0D108BD9-81ED-4DB2-BD59-A6C34878D82A}">
+                    <a16:rowId xmlns:a16="http://schemas.microsoft.com/office/drawing/2014/main" val="10002"/>
+                  </a:ext>
+                </a:extLst>
               </a:tr>
               <a:tr h="320040">
                 <a:tc>
@@ -5562,7 +5380,7 @@
                     <a:bodyPr/>
                     <a:lstStyle/>
                     <a:p>
-                      <a:pPr indent="0" marL="0">
+                      <a:pPr marL="0" indent="0">
                         <a:buNone/>
                       </a:pPr>
                       <a:r>
@@ -5576,7 +5394,7 @@
                       <a:endParaRPr lang="en-US" sz="900" dirty="0"/>
                     </a:p>
                   </a:txBody>
-                  <a:tcPr marL="91440" marR="91440" marT="45720" marB="45720">
+                  <a:tcPr>
                     <a:lnL w="6350" cap="flat" cmpd="sng" algn="ctr">
                       <a:solidFill>
                         <a:srgbClr val="0A3D5C"/>
@@ -5623,7 +5441,7 @@
                     <a:bodyPr/>
                     <a:lstStyle/>
                     <a:p>
-                      <a:pPr indent="0" marL="0">
+                      <a:pPr marL="0" indent="0">
                         <a:buNone/>
                       </a:pPr>
                       <a:r>
@@ -5637,7 +5455,7 @@
                       <a:endParaRPr lang="en-US" sz="900" dirty="0"/>
                     </a:p>
                   </a:txBody>
-                  <a:tcPr marL="91440" marR="91440" marT="45720" marB="45720">
+                  <a:tcPr>
                     <a:lnL w="6350" cap="flat" cmpd="sng" algn="ctr">
                       <a:solidFill>
                         <a:srgbClr val="0A3D5C"/>
@@ -5684,7 +5502,7 @@
                     <a:bodyPr/>
                     <a:lstStyle/>
                     <a:p>
-                      <a:pPr indent="0" marL="0">
+                      <a:pPr marL="0" indent="0">
                         <a:buNone/>
                       </a:pPr>
                       <a:r>
@@ -5698,7 +5516,7 @@
                       <a:endParaRPr lang="en-US" sz="900" dirty="0"/>
                     </a:p>
                   </a:txBody>
-                  <a:tcPr marL="91440" marR="91440" marT="45720" marB="45720">
+                  <a:tcPr>
                     <a:lnL w="6350" cap="flat" cmpd="sng" algn="ctr">
                       <a:solidFill>
                         <a:srgbClr val="0A3D5C"/>
@@ -5740,6 +5558,11 @@
                     </a:solidFill>
                   </a:tcPr>
                 </a:tc>
+                <a:extLst>
+                  <a:ext uri="{0D108BD9-81ED-4DB2-BD59-A6C34878D82A}">
+                    <a16:rowId xmlns:a16="http://schemas.microsoft.com/office/drawing/2014/main" val="10003"/>
+                  </a:ext>
+                </a:extLst>
               </a:tr>
               <a:tr h="320040">
                 <a:tc>
@@ -5747,7 +5570,7 @@
                     <a:bodyPr/>
                     <a:lstStyle/>
                     <a:p>
-                      <a:pPr indent="0" marL="0">
+                      <a:pPr marL="0" indent="0">
                         <a:buNone/>
                       </a:pPr>
                       <a:r>
@@ -5761,7 +5584,7 @@
                       <a:endParaRPr lang="en-US" sz="900" dirty="0"/>
                     </a:p>
                   </a:txBody>
-                  <a:tcPr marL="91440" marR="91440" marT="45720" marB="45720">
+                  <a:tcPr>
                     <a:lnL w="6350" cap="flat" cmpd="sng" algn="ctr">
                       <a:solidFill>
                         <a:srgbClr val="0A3D5C"/>
@@ -5808,7 +5631,7 @@
                     <a:bodyPr/>
                     <a:lstStyle/>
                     <a:p>
-                      <a:pPr indent="0" marL="0">
+                      <a:pPr marL="0" indent="0">
                         <a:buNone/>
                       </a:pPr>
                       <a:r>
@@ -5822,7 +5645,7 @@
                       <a:endParaRPr lang="en-US" sz="900" dirty="0"/>
                     </a:p>
                   </a:txBody>
-                  <a:tcPr marL="91440" marR="91440" marT="45720" marB="45720">
+                  <a:tcPr>
                     <a:lnL w="6350" cap="flat" cmpd="sng" algn="ctr">
                       <a:solidFill>
                         <a:srgbClr val="0A3D5C"/>
@@ -5869,7 +5692,7 @@
                     <a:bodyPr/>
                     <a:lstStyle/>
                     <a:p>
-                      <a:pPr indent="0" marL="0">
+                      <a:pPr marL="0" indent="0">
                         <a:buNone/>
                       </a:pPr>
                       <a:r>
@@ -5883,7 +5706,7 @@
                       <a:endParaRPr lang="en-US" sz="900" dirty="0"/>
                     </a:p>
                   </a:txBody>
-                  <a:tcPr marL="91440" marR="91440" marT="45720" marB="45720">
+                  <a:tcPr>
                     <a:lnL w="6350" cap="flat" cmpd="sng" algn="ctr">
                       <a:solidFill>
                         <a:srgbClr val="0A3D5C"/>
@@ -5925,6 +5748,11 @@
                     </a:solidFill>
                   </a:tcPr>
                 </a:tc>
+                <a:extLst>
+                  <a:ext uri="{0D108BD9-81ED-4DB2-BD59-A6C34878D82A}">
+                    <a16:rowId xmlns:a16="http://schemas.microsoft.com/office/drawing/2014/main" val="10004"/>
+                  </a:ext>
+                </a:extLst>
               </a:tr>
               <a:tr h="320040">
                 <a:tc>
@@ -5932,7 +5760,7 @@
                     <a:bodyPr/>
                     <a:lstStyle/>
                     <a:p>
-                      <a:pPr indent="0" marL="0">
+                      <a:pPr marL="0" indent="0">
                         <a:buNone/>
                       </a:pPr>
                       <a:r>
@@ -5946,7 +5774,7 @@
                       <a:endParaRPr lang="en-US" sz="900" dirty="0"/>
                     </a:p>
                   </a:txBody>
-                  <a:tcPr marL="91440" marR="91440" marT="45720" marB="45720">
+                  <a:tcPr>
                     <a:lnL w="6350" cap="flat" cmpd="sng" algn="ctr">
                       <a:solidFill>
                         <a:srgbClr val="0A3D5C"/>
@@ -5993,7 +5821,7 @@
                     <a:bodyPr/>
                     <a:lstStyle/>
                     <a:p>
-                      <a:pPr indent="0" marL="0">
+                      <a:pPr marL="0" indent="0">
                         <a:buNone/>
                       </a:pPr>
                       <a:r>
@@ -6007,7 +5835,7 @@
                       <a:endParaRPr lang="en-US" sz="900" dirty="0"/>
                     </a:p>
                   </a:txBody>
-                  <a:tcPr marL="91440" marR="91440" marT="45720" marB="45720">
+                  <a:tcPr>
                     <a:lnL w="6350" cap="flat" cmpd="sng" algn="ctr">
                       <a:solidFill>
                         <a:srgbClr val="0A3D5C"/>
@@ -6054,7 +5882,7 @@
                     <a:bodyPr/>
                     <a:lstStyle/>
                     <a:p>
-                      <a:pPr indent="0" marL="0">
+                      <a:pPr marL="0" indent="0">
                         <a:buNone/>
                       </a:pPr>
                       <a:r>
@@ -6068,7 +5896,7 @@
                       <a:endParaRPr lang="en-US" sz="900" dirty="0"/>
                     </a:p>
                   </a:txBody>
-                  <a:tcPr marL="91440" marR="91440" marT="45720" marB="45720">
+                  <a:tcPr>
                     <a:lnL w="6350" cap="flat" cmpd="sng" algn="ctr">
                       <a:solidFill>
                         <a:srgbClr val="0A3D5C"/>
@@ -6110,6 +5938,11 @@
                     </a:solidFill>
                   </a:tcPr>
                 </a:tc>
+                <a:extLst>
+                  <a:ext uri="{0D108BD9-81ED-4DB2-BD59-A6C34878D82A}">
+                    <a16:rowId xmlns:a16="http://schemas.microsoft.com/office/drawing/2014/main" val="10005"/>
+                  </a:ext>
+                </a:extLst>
               </a:tr>
             </a:tbl>
           </a:graphicData>
@@ -6131,6 +5964,7 @@
         <a:solidFill>
           <a:srgbClr val="0B0E17"/>
         </a:solidFill>
+        <a:effectLst/>
       </p:bgPr>
     </p:bg>
     <p:spTree>
@@ -6300,7 +6134,7 @@
           <a:bodyPr wrap="square" lIns="0" tIns="0" rIns="0" bIns="0" rtlCol="0" anchor="ctr"/>
           <a:lstStyle/>
           <a:p>
-            <a:pPr indent="0" marL="0">
+            <a:pPr marL="0" indent="0">
               <a:buNone/>
             </a:pPr>
             <a:r>
@@ -6339,11 +6173,11 @@
           <a:bodyPr wrap="square" lIns="0" tIns="0" rIns="0" bIns="0" rtlCol="0" anchor="ctr"/>
           <a:lstStyle/>
           <a:p>
-            <a:pPr indent="0" marL="0">
+            <a:pPr marL="0" indent="0">
               <a:buNone/>
             </a:pPr>
             <a:r>
-              <a:rPr lang="en-US" sz="2200" spc="200" kern="0" dirty="0">
+              <a:rPr lang="en-US" sz="2200" kern="0" spc="200" dirty="0">
                 <a:solidFill>
                   <a:srgbClr val="F0F0F0"/>
                 </a:solidFill>
@@ -6401,7 +6235,7 @@
           <a:bodyPr wrap="square" lIns="0" tIns="0" rIns="0" bIns="0" rtlCol="0" anchor="ctr"/>
           <a:lstStyle/>
           <a:p>
-            <a:pPr indent="0" marL="0">
+            <a:pPr marL="0" indent="0">
               <a:buNone/>
             </a:pPr>
             <a:r>
@@ -6546,7 +6380,7 @@
           <a:bodyPr wrap="square" lIns="0" tIns="0" rIns="0" bIns="0" rtlCol="0" anchor="ctr"/>
           <a:lstStyle/>
           <a:p>
-            <a:pPr indent="0" marL="0">
+            <a:pPr marL="0" indent="0">
               <a:buNone/>
             </a:pPr>
             <a:r>
@@ -6691,7 +6525,7 @@
           <a:bodyPr wrap="square" lIns="0" tIns="0" rIns="0" bIns="0" rtlCol="0" anchor="ctr"/>
           <a:lstStyle/>
           <a:p>
-            <a:pPr indent="0" marL="0">
+            <a:pPr marL="0" indent="0">
               <a:buNone/>
             </a:pPr>
             <a:r>
@@ -6725,6 +6559,7 @@
         <a:solidFill>
           <a:srgbClr val="0B0E17"/>
         </a:solidFill>
+        <a:effectLst/>
       </p:bgPr>
     </p:bg>
     <p:spTree>
@@ -6894,7 +6729,7 @@
           <a:bodyPr wrap="square" lIns="0" tIns="0" rIns="0" bIns="0" rtlCol="0" anchor="ctr"/>
           <a:lstStyle/>
           <a:p>
-            <a:pPr indent="0" marL="0">
+            <a:pPr marL="0" indent="0">
               <a:buNone/>
             </a:pPr>
             <a:r>
@@ -6933,11 +6768,11 @@
           <a:bodyPr wrap="square" lIns="0" tIns="0" rIns="0" bIns="0" rtlCol="0" anchor="ctr"/>
           <a:lstStyle/>
           <a:p>
-            <a:pPr indent="0" marL="0">
+            <a:pPr marL="0" indent="0">
               <a:buNone/>
             </a:pPr>
             <a:r>
-              <a:rPr lang="en-US" sz="2200" spc="200" kern="0" dirty="0">
+              <a:rPr lang="en-US" sz="2200" kern="0" spc="200" dirty="0">
                 <a:solidFill>
                   <a:srgbClr val="F0F0F0"/>
                 </a:solidFill>
@@ -6995,7 +6830,7 @@
           <a:bodyPr wrap="square" lIns="0" tIns="0" rIns="0" bIns="0" rtlCol="0" anchor="ctr"/>
           <a:lstStyle/>
           <a:p>
-            <a:pPr indent="0" marL="0">
+            <a:pPr marL="0" indent="0">
               <a:buNone/>
             </a:pPr>
             <a:r>
@@ -7054,7 +6889,7 @@
           <a:bodyPr wrap="square" lIns="0" tIns="0" rIns="0" bIns="0" rtlCol="0" anchor="ctr"/>
           <a:lstStyle/>
           <a:p>
-            <a:pPr indent="0" marL="0">
+            <a:pPr marL="0" indent="0">
               <a:buNone/>
             </a:pPr>
             <a:r>
@@ -7093,7 +6928,7 @@
           <a:bodyPr wrap="square" lIns="0" tIns="0" rIns="0" bIns="0" rtlCol="0" anchor="ctr"/>
           <a:lstStyle/>
           <a:p>
-            <a:pPr indent="0" marL="0">
+            <a:pPr marL="0" indent="0">
               <a:buNone/>
             </a:pPr>
             <a:r>
@@ -7152,7 +6987,7 @@
           <a:bodyPr wrap="square" lIns="0" tIns="0" rIns="0" bIns="0" rtlCol="0" anchor="ctr"/>
           <a:lstStyle/>
           <a:p>
-            <a:pPr indent="0" marL="0">
+            <a:pPr marL="0" indent="0">
               <a:buNone/>
             </a:pPr>
             <a:r>
@@ -7191,7 +7026,7 @@
           <a:bodyPr wrap="square" lIns="0" tIns="0" rIns="0" bIns="0" rtlCol="0" anchor="ctr"/>
           <a:lstStyle/>
           <a:p>
-            <a:pPr indent="0" marL="0">
+            <a:pPr marL="0" indent="0">
               <a:buNone/>
             </a:pPr>
             <a:r>
@@ -7250,7 +7085,7 @@
           <a:bodyPr wrap="square" lIns="0" tIns="0" rIns="0" bIns="0" rtlCol="0" anchor="ctr"/>
           <a:lstStyle/>
           <a:p>
-            <a:pPr indent="0" marL="0">
+            <a:pPr marL="0" indent="0">
               <a:buNone/>
             </a:pPr>
             <a:r>
@@ -7289,7 +7124,7 @@
           <a:bodyPr wrap="square" lIns="0" tIns="0" rIns="0" bIns="0" rtlCol="0" anchor="ctr"/>
           <a:lstStyle/>
           <a:p>
-            <a:pPr indent="0" marL="0">
+            <a:pPr marL="0" indent="0">
               <a:buNone/>
             </a:pPr>
             <a:r>
@@ -7323,6 +7158,7 @@
         <a:solidFill>
           <a:srgbClr val="0B0E17"/>
         </a:solidFill>
+        <a:effectLst/>
       </p:bgPr>
     </p:bg>
     <p:spTree>
@@ -7492,7 +7328,7 @@
           <a:bodyPr wrap="square" lIns="0" tIns="0" rIns="0" bIns="0" rtlCol="0" anchor="ctr"/>
           <a:lstStyle/>
           <a:p>
-            <a:pPr indent="0" marL="0">
+            <a:pPr marL="0" indent="0">
               <a:buNone/>
             </a:pPr>
             <a:r>
@@ -7531,11 +7367,11 @@
           <a:bodyPr wrap="square" lIns="0" tIns="0" rIns="0" bIns="0" rtlCol="0" anchor="ctr"/>
           <a:lstStyle/>
           <a:p>
-            <a:pPr indent="0" marL="0">
+            <a:pPr marL="0" indent="0">
               <a:buNone/>
             </a:pPr>
             <a:r>
-              <a:rPr lang="en-US" sz="2200" spc="200" kern="0" dirty="0">
+              <a:rPr lang="en-US" sz="2200" kern="0" spc="200" dirty="0">
                 <a:solidFill>
                   <a:srgbClr val="F0F0F0"/>
                 </a:solidFill>
@@ -7636,7 +7472,7 @@
           <a:bodyPr wrap="square" lIns="0" tIns="0" rIns="0" bIns="0" rtlCol="0" anchor="ctr"/>
           <a:lstStyle/>
           <a:p>
-            <a:pPr indent="0" marL="0">
+            <a:pPr marL="0" indent="0">
               <a:buNone/>
             </a:pPr>
             <a:r>
@@ -7675,7 +7511,7 @@
           <a:bodyPr wrap="square" lIns="0" tIns="0" rIns="0" bIns="0" rtlCol="0" anchor="ctr"/>
           <a:lstStyle/>
           <a:p>
-            <a:pPr indent="0" marL="0">
+            <a:pPr marL="0" indent="0">
               <a:buNone/>
             </a:pPr>
             <a:r>
@@ -7714,7 +7550,7 @@
           <a:bodyPr wrap="square" lIns="0" tIns="0" rIns="0" bIns="0" rtlCol="0" anchor="t"/>
           <a:lstStyle/>
           <a:p>
-            <a:pPr indent="0" marL="0">
+            <a:pPr marL="0" indent="0">
               <a:lnSpc>
                 <a:spcPct val="120000"/>
               </a:lnSpc>
@@ -7776,7 +7612,7 @@
           <a:bodyPr wrap="square" lIns="0" tIns="0" rIns="0" bIns="0" rtlCol="0" anchor="ctr"/>
           <a:lstStyle/>
           <a:p>
-            <a:pPr indent="0" marL="0">
+            <a:pPr marL="0" indent="0">
               <a:buNone/>
             </a:pPr>
             <a:r>
@@ -7815,7 +7651,7 @@
           <a:bodyPr wrap="square" lIns="0" tIns="0" rIns="0" bIns="0" rtlCol="0" anchor="ctr"/>
           <a:lstStyle/>
           <a:p>
-            <a:pPr indent="0" marL="0">
+            <a:pPr marL="0" indent="0">
               <a:buNone/>
             </a:pPr>
             <a:r>
@@ -7854,7 +7690,7 @@
           <a:bodyPr wrap="square" lIns="0" tIns="0" rIns="0" bIns="0" rtlCol="0" anchor="t"/>
           <a:lstStyle/>
           <a:p>
-            <a:pPr indent="0" marL="0">
+            <a:pPr marL="0" indent="0">
               <a:lnSpc>
                 <a:spcPct val="120000"/>
               </a:lnSpc>
@@ -7916,7 +7752,7 @@
           <a:bodyPr wrap="square" lIns="0" tIns="0" rIns="0" bIns="0" rtlCol="0" anchor="ctr"/>
           <a:lstStyle/>
           <a:p>
-            <a:pPr indent="0" marL="0">
+            <a:pPr marL="0" indent="0">
               <a:buNone/>
             </a:pPr>
             <a:r>
@@ -7955,7 +7791,7 @@
           <a:bodyPr wrap="square" lIns="0" tIns="0" rIns="0" bIns="0" rtlCol="0" anchor="ctr"/>
           <a:lstStyle/>
           <a:p>
-            <a:pPr indent="0" marL="0">
+            <a:pPr marL="0" indent="0">
               <a:buNone/>
             </a:pPr>
             <a:r>
@@ -7994,7 +7830,7 @@
           <a:bodyPr wrap="square" lIns="0" tIns="0" rIns="0" bIns="0" rtlCol="0" anchor="t"/>
           <a:lstStyle/>
           <a:p>
-            <a:pPr indent="0" marL="0">
+            <a:pPr marL="0" indent="0">
               <a:lnSpc>
                 <a:spcPct val="120000"/>
               </a:lnSpc>
@@ -8056,7 +7892,7 @@
           <a:bodyPr wrap="square" lIns="0" tIns="0" rIns="0" bIns="0" rtlCol="0" anchor="ctr"/>
           <a:lstStyle/>
           <a:p>
-            <a:pPr indent="0" marL="0">
+            <a:pPr marL="0" indent="0">
               <a:buNone/>
             </a:pPr>
             <a:r>
@@ -8095,7 +7931,7 @@
           <a:bodyPr wrap="square" lIns="0" tIns="0" rIns="0" bIns="0" rtlCol="0" anchor="ctr"/>
           <a:lstStyle/>
           <a:p>
-            <a:pPr indent="0" marL="0">
+            <a:pPr marL="0" indent="0">
               <a:buNone/>
             </a:pPr>
             <a:r>
@@ -8134,7 +7970,7 @@
           <a:bodyPr wrap="square" lIns="0" tIns="0" rIns="0" bIns="0" rtlCol="0" anchor="t"/>
           <a:lstStyle/>
           <a:p>
-            <a:pPr indent="0" marL="0">
+            <a:pPr marL="0" indent="0">
               <a:lnSpc>
                 <a:spcPct val="120000"/>
               </a:lnSpc>
@@ -8196,7 +8032,7 @@
           <a:bodyPr wrap="square" lIns="0" tIns="0" rIns="0" bIns="0" rtlCol="0" anchor="ctr"/>
           <a:lstStyle/>
           <a:p>
-            <a:pPr indent="0" marL="0">
+            <a:pPr marL="0" indent="0">
               <a:buNone/>
             </a:pPr>
             <a:r>
@@ -8235,7 +8071,7 @@
           <a:bodyPr wrap="square" lIns="0" tIns="0" rIns="0" bIns="0" rtlCol="0" anchor="ctr"/>
           <a:lstStyle/>
           <a:p>
-            <a:pPr indent="0" marL="0">
+            <a:pPr marL="0" indent="0">
               <a:buNone/>
             </a:pPr>
             <a:r>
@@ -8274,7 +8110,7 @@
           <a:bodyPr wrap="square" lIns="0" tIns="0" rIns="0" bIns="0" rtlCol="0" anchor="t"/>
           <a:lstStyle/>
           <a:p>
-            <a:pPr indent="0" marL="0">
+            <a:pPr marL="0" indent="0">
               <a:lnSpc>
                 <a:spcPct val="120000"/>
               </a:lnSpc>
@@ -8596,4 +8432,299 @@
     </a:ext>
   </a:extLst>
 </a:theme>
+</file>
+
+<file path=ppt/theme/theme2.xml><?xml version="1.0" encoding="utf-8"?>
+<a:theme xmlns:a="http://schemas.openxmlformats.org/drawingml/2006/main" name="Тема Office">
+  <a:themeElements>
+    <a:clrScheme name="Стандартная">
+      <a:dk1>
+        <a:sysClr val="windowText" lastClr="000000"/>
+      </a:dk1>
+      <a:lt1>
+        <a:sysClr val="window" lastClr="FFFFFF"/>
+      </a:lt1>
+      <a:dk2>
+        <a:srgbClr val="44546A"/>
+      </a:dk2>
+      <a:lt2>
+        <a:srgbClr val="E7E6E6"/>
+      </a:lt2>
+      <a:accent1>
+        <a:srgbClr val="4472C4"/>
+      </a:accent1>
+      <a:accent2>
+        <a:srgbClr val="ED7D31"/>
+      </a:accent2>
+      <a:accent3>
+        <a:srgbClr val="A5A5A5"/>
+      </a:accent3>
+      <a:accent4>
+        <a:srgbClr val="FFC000"/>
+      </a:accent4>
+      <a:accent5>
+        <a:srgbClr val="5B9BD5"/>
+      </a:accent5>
+      <a:accent6>
+        <a:srgbClr val="70AD47"/>
+      </a:accent6>
+      <a:hlink>
+        <a:srgbClr val="0563C1"/>
+      </a:hlink>
+      <a:folHlink>
+        <a:srgbClr val="954F72"/>
+      </a:folHlink>
+    </a:clrScheme>
+    <a:fontScheme name="Стандартная">
+      <a:majorFont>
+        <a:latin typeface="Calibri Light" panose="020F0302020204030204"/>
+        <a:ea typeface=""/>
+        <a:cs typeface=""/>
+        <a:font script="Jpan" typeface="游ゴシック Light"/>
+        <a:font script="Hang" typeface="맑은 고딕"/>
+        <a:font script="Hans" typeface="等线 Light"/>
+        <a:font script="Hant" typeface="新細明體"/>
+        <a:font script="Arab" typeface="Times New Roman"/>
+        <a:font script="Hebr" typeface="Times New Roman"/>
+        <a:font script="Thai" typeface="Angsana New"/>
+        <a:font script="Ethi" typeface="Nyala"/>
+        <a:font script="Beng" typeface="Vrinda"/>
+        <a:font script="Gujr" typeface="Shruti"/>
+        <a:font script="Khmr" typeface="MoolBoran"/>
+        <a:font script="Knda" typeface="Tunga"/>
+        <a:font script="Guru" typeface="Raavi"/>
+        <a:font script="Cans" typeface="Euphemia"/>
+        <a:font script="Cher" typeface="Plantagenet Cherokee"/>
+        <a:font script="Yiii" typeface="Microsoft Yi Baiti"/>
+        <a:font script="Tibt" typeface="Microsoft Himalaya"/>
+        <a:font script="Thaa" typeface="MV Boli"/>
+        <a:font script="Deva" typeface="Mangal"/>
+        <a:font script="Telu" typeface="Gautami"/>
+        <a:font script="Taml" typeface="Latha"/>
+        <a:font script="Syrc" typeface="Estrangelo Edessa"/>
+        <a:font script="Orya" typeface="Kalinga"/>
+        <a:font script="Mlym" typeface="Kartika"/>
+        <a:font script="Laoo" typeface="DokChampa"/>
+        <a:font script="Sinh" typeface="Iskoola Pota"/>
+        <a:font script="Mong" typeface="Mongolian Baiti"/>
+        <a:font script="Viet" typeface="Times New Roman"/>
+        <a:font script="Uigh" typeface="Microsoft Uighur"/>
+        <a:font script="Geor" typeface="Sylfaen"/>
+        <a:font script="Armn" typeface="Arial"/>
+        <a:font script="Bugi" typeface="Leelawadee UI"/>
+        <a:font script="Bopo" typeface="Microsoft JhengHei"/>
+        <a:font script="Java" typeface="Javanese Text"/>
+        <a:font script="Lisu" typeface="Segoe UI"/>
+        <a:font script="Mymr" typeface="Myanmar Text"/>
+        <a:font script="Nkoo" typeface="Ebrima"/>
+        <a:font script="Olck" typeface="Nirmala UI"/>
+        <a:font script="Osma" typeface="Ebrima"/>
+        <a:font script="Phag" typeface="Phagspa"/>
+        <a:font script="Syrn" typeface="Estrangelo Edessa"/>
+        <a:font script="Syrj" typeface="Estrangelo Edessa"/>
+        <a:font script="Syre" typeface="Estrangelo Edessa"/>
+        <a:font script="Sora" typeface="Nirmala UI"/>
+        <a:font script="Tale" typeface="Microsoft Tai Le"/>
+        <a:font script="Talu" typeface="Microsoft New Tai Lue"/>
+        <a:font script="Tfng" typeface="Ebrima"/>
+      </a:majorFont>
+      <a:minorFont>
+        <a:latin typeface="Calibri" panose="020F0502020204030204"/>
+        <a:ea typeface=""/>
+        <a:cs typeface=""/>
+        <a:font script="Jpan" typeface="游ゴシック"/>
+        <a:font script="Hang" typeface="맑은 고딕"/>
+        <a:font script="Hans" typeface="等线"/>
+        <a:font script="Hant" typeface="新細明體"/>
+        <a:font script="Arab" typeface="Arial"/>
+        <a:font script="Hebr" typeface="Arial"/>
+        <a:font script="Thai" typeface="Cordia New"/>
+        <a:font script="Ethi" typeface="Nyala"/>
+        <a:font script="Beng" typeface="Vrinda"/>
+        <a:font script="Gujr" typeface="Shruti"/>
+        <a:font script="Khmr" typeface="DaunPenh"/>
+        <a:font script="Knda" typeface="Tunga"/>
+        <a:font script="Guru" typeface="Raavi"/>
+        <a:font script="Cans" typeface="Euphemia"/>
+        <a:font script="Cher" typeface="Plantagenet Cherokee"/>
+        <a:font script="Yiii" typeface="Microsoft Yi Baiti"/>
+        <a:font script="Tibt" typeface="Microsoft Himalaya"/>
+        <a:font script="Thaa" typeface="MV Boli"/>
+        <a:font script="Deva" typeface="Mangal"/>
+        <a:font script="Telu" typeface="Gautami"/>
+        <a:font script="Taml" typeface="Latha"/>
+        <a:font script="Syrc" typeface="Estrangelo Edessa"/>
+        <a:font script="Orya" typeface="Kalinga"/>
+        <a:font script="Mlym" typeface="Kartika"/>
+        <a:font script="Laoo" typeface="DokChampa"/>
+        <a:font script="Sinh" typeface="Iskoola Pota"/>
+        <a:font script="Mong" typeface="Mongolian Baiti"/>
+        <a:font script="Viet" typeface="Arial"/>
+        <a:font script="Uigh" typeface="Microsoft Uighur"/>
+        <a:font script="Geor" typeface="Sylfaen"/>
+        <a:font script="Armn" typeface="Arial"/>
+        <a:font script="Bugi" typeface="Leelawadee UI"/>
+        <a:font script="Bopo" typeface="Microsoft JhengHei"/>
+        <a:font script="Java" typeface="Javanese Text"/>
+        <a:font script="Lisu" typeface="Segoe UI"/>
+        <a:font script="Mymr" typeface="Myanmar Text"/>
+        <a:font script="Nkoo" typeface="Ebrima"/>
+        <a:font script="Olck" typeface="Nirmala UI"/>
+        <a:font script="Osma" typeface="Ebrima"/>
+        <a:font script="Phag" typeface="Phagspa"/>
+        <a:font script="Syrn" typeface="Estrangelo Edessa"/>
+        <a:font script="Syrj" typeface="Estrangelo Edessa"/>
+        <a:font script="Syre" typeface="Estrangelo Edessa"/>
+        <a:font script="Sora" typeface="Nirmala UI"/>
+        <a:font script="Tale" typeface="Microsoft Tai Le"/>
+        <a:font script="Talu" typeface="Microsoft New Tai Lue"/>
+        <a:font script="Tfng" typeface="Ebrima"/>
+      </a:minorFont>
+    </a:fontScheme>
+    <a:fmtScheme name="Стандартная">
+      <a:fillStyleLst>
+        <a:solidFill>
+          <a:schemeClr val="phClr"/>
+        </a:solidFill>
+        <a:gradFill rotWithShape="1">
+          <a:gsLst>
+            <a:gs pos="0">
+              <a:schemeClr val="phClr">
+                <a:lumMod val="110000"/>
+                <a:satMod val="105000"/>
+                <a:tint val="67000"/>
+              </a:schemeClr>
+            </a:gs>
+            <a:gs pos="50000">
+              <a:schemeClr val="phClr">
+                <a:lumMod val="105000"/>
+                <a:satMod val="103000"/>
+                <a:tint val="73000"/>
+              </a:schemeClr>
+            </a:gs>
+            <a:gs pos="100000">
+              <a:schemeClr val="phClr">
+                <a:lumMod val="105000"/>
+                <a:satMod val="109000"/>
+                <a:tint val="81000"/>
+              </a:schemeClr>
+            </a:gs>
+          </a:gsLst>
+          <a:lin ang="5400000" scaled="0"/>
+        </a:gradFill>
+        <a:gradFill rotWithShape="1">
+          <a:gsLst>
+            <a:gs pos="0">
+              <a:schemeClr val="phClr">
+                <a:satMod val="103000"/>
+                <a:lumMod val="102000"/>
+                <a:tint val="94000"/>
+              </a:schemeClr>
+            </a:gs>
+            <a:gs pos="50000">
+              <a:schemeClr val="phClr">
+                <a:satMod val="110000"/>
+                <a:lumMod val="100000"/>
+                <a:shade val="100000"/>
+              </a:schemeClr>
+            </a:gs>
+            <a:gs pos="100000">
+              <a:schemeClr val="phClr">
+                <a:lumMod val="99000"/>
+                <a:satMod val="120000"/>
+                <a:shade val="78000"/>
+              </a:schemeClr>
+            </a:gs>
+          </a:gsLst>
+          <a:lin ang="5400000" scaled="0"/>
+        </a:gradFill>
+      </a:fillStyleLst>
+      <a:lnStyleLst>
+        <a:ln w="6350" cap="flat" cmpd="sng" algn="ctr">
+          <a:solidFill>
+            <a:schemeClr val="phClr"/>
+          </a:solidFill>
+          <a:prstDash val="solid"/>
+          <a:miter lim="800000"/>
+        </a:ln>
+        <a:ln w="12700" cap="flat" cmpd="sng" algn="ctr">
+          <a:solidFill>
+            <a:schemeClr val="phClr"/>
+          </a:solidFill>
+          <a:prstDash val="solid"/>
+          <a:miter lim="800000"/>
+        </a:ln>
+        <a:ln w="19050" cap="flat" cmpd="sng" algn="ctr">
+          <a:solidFill>
+            <a:schemeClr val="phClr"/>
+          </a:solidFill>
+          <a:prstDash val="solid"/>
+          <a:miter lim="800000"/>
+        </a:ln>
+      </a:lnStyleLst>
+      <a:effectStyleLst>
+        <a:effectStyle>
+          <a:effectLst/>
+        </a:effectStyle>
+        <a:effectStyle>
+          <a:effectLst/>
+        </a:effectStyle>
+        <a:effectStyle>
+          <a:effectLst>
+            <a:outerShdw blurRad="57150" dist="19050" dir="5400000" algn="ctr" rotWithShape="0">
+              <a:srgbClr val="000000">
+                <a:alpha val="63000"/>
+              </a:srgbClr>
+            </a:outerShdw>
+          </a:effectLst>
+        </a:effectStyle>
+      </a:effectStyleLst>
+      <a:bgFillStyleLst>
+        <a:solidFill>
+          <a:schemeClr val="phClr"/>
+        </a:solidFill>
+        <a:solidFill>
+          <a:schemeClr val="phClr">
+            <a:tint val="95000"/>
+            <a:satMod val="170000"/>
+          </a:schemeClr>
+        </a:solidFill>
+        <a:gradFill rotWithShape="1">
+          <a:gsLst>
+            <a:gs pos="0">
+              <a:schemeClr val="phClr">
+                <a:tint val="93000"/>
+                <a:satMod val="150000"/>
+                <a:shade val="98000"/>
+                <a:lumMod val="102000"/>
+              </a:schemeClr>
+            </a:gs>
+            <a:gs pos="50000">
+              <a:schemeClr val="phClr">
+                <a:tint val="98000"/>
+                <a:satMod val="130000"/>
+                <a:shade val="90000"/>
+                <a:lumMod val="103000"/>
+              </a:schemeClr>
+            </a:gs>
+            <a:gs pos="100000">
+              <a:schemeClr val="phClr">
+                <a:shade val="63000"/>
+                <a:satMod val="120000"/>
+              </a:schemeClr>
+            </a:gs>
+          </a:gsLst>
+          <a:lin ang="5400000" scaled="0"/>
+        </a:gradFill>
+      </a:bgFillStyleLst>
+    </a:fmtScheme>
+  </a:themeElements>
+  <a:objectDefaults/>
+  <a:extraClrSchemeLst/>
+  <a:extLst>
+    <a:ext uri="{05A4C25C-085E-4340-85A3-A5531E510DB2}">
+      <thm15:themeFamily xmlns:thm15="http://schemas.microsoft.com/office/thememl/2012/main" name="Office Theme" id="{62F939B6-93AF-4DB8-9C6B-D6C7DFDC589F}" vid="{4A3C46E8-61CC-4603-A589-7422A47A8E4A}"/>
+    </a:ext>
+  </a:extLst>
+</a:theme>
 </file>
</xml_diff>